<commit_message>
feat: minimal simulator feed script + e2e smoke test
</commit_message>
<xml_diff>
--- a/bp/家安housafe_BP.pptx
+++ b/bp/家安housafe_BP.pptx
@@ -14308,7 +14308,7 @@
                 <a:latin typeface="Arial"/>
                 <a:ea typeface="微软雅黑"/>
               </a:rPr>
-              <a:t>子女带回家，一人操作、15 分钟装完、无需工具。雷达 7×24 采集，云端 AI 识别异常，异地子女第一时间知道。老人不穿戴、不操作——对外只说是"自动感应开灯的"。系统检测到长期两人同住时自动降级为基础报警模式。</a:t>
+              <a:t>子女带回家，一人操作、15 分钟装完、无需工具。雷达 7×24 采集原始点云，云端 ELPD 世界模型持续理解老人状态，异常分级通知异地子女。老人不穿戴、不操作——对外只说是"自动感应开灯的"。系统检测到长期两人同住时自动降级为基础报警模式。</a:t>
             </a:r>
           </a:p>
         </p:txBody>
@@ -14564,7 +14564,7 @@
                 <a:latin typeface="Arial"/>
                 <a:ea typeface="微软雅黑"/>
               </a:rPr>
-              <a:t>云端 AI 点云理解</a:t>
+              <a:t>ELPD 世界模型 · 隐空间理解</a:t>
             </a:r>
           </a:p>
         </p:txBody>
@@ -14604,7 +14604,7 @@
                 <a:latin typeface="Arial"/>
                 <a:ea typeface="微软雅黑"/>
               </a:rPr>
-              <a:t>原始点云通过 WiFi 直传云端，GPU 自研模型从点云中同时提取姿态序列、速度分布、点云形变、微多普勒谱、生命体征、活动片段六类信号。识别跌倒/长时间静止/体征异常/模式偏离四类事件。</a:t>
+              <a:t>原始点云 WiFi 直传云端，Encoder 压缩为统一隐空间表征 S_t，Predictor 学习老人行为动力学、预测下一时刻状态。同一隐空间同时产出姿态序列、速度分布、点云形变、微多普勒谱、生命体征、活动片段六类信号。识别跌倒/静止/体征异常/模式偏离四类事件。</a:t>
             </a:r>
           </a:p>
         </p:txBody>
@@ -14712,7 +14712,7 @@
                 <a:latin typeface="Arial"/>
                 <a:ea typeface="微软雅黑"/>
               </a:rPr>
-              <a:t>延迟确认降误报</a:t>
+              <a:t>Predictor 预测偏差 · 延迟确认</a:t>
             </a:r>
           </a:p>
         </p:txBody>
@@ -14752,7 +14752,7 @@
                 <a:latin typeface="Arial"/>
                 <a:ea typeface="微软雅黑"/>
               </a:rPr>
-              <a:t>跌倒初判后等 3–5 秒观察后续行为，多雷达交叉验证，结合 14 天个人基线。区分真摔与快速坐下/蹲下/弯腰捡物——这是厂商固件做不到的，因为固件没有个人的"正常"做参照。</a:t>
+              <a:t>跌倒初判后等 3–5 秒观察后续行为，多雷达交叉验证。Predictor 对比"预测状态"与"真实状态"——预测偏差即异常信号，结合 14 天个人基线，区分真摔与快速坐下/蹲下/弯腰捡物。厂商固件没有隐空间表征，无法做预测对比。</a:t>
             </a:r>
           </a:p>
         </p:txBody>
@@ -15381,7 +15381,7 @@
                 <a:latin typeface="Arial"/>
                 <a:ea typeface="微软雅黑"/>
               </a:rPr>
-              <a:t>核心价值：无感 · 准 · 有预判 · 不骚扰。独居为核心设计场景，夫妻同居提供基础紧急报警。</a:t>
+              <a:t>核心价值：ELPD 世界模型驱动的全屋无感守护——从原始点云到隐空间理解，越用越准。独居为核心设计场景，夫妻同居提供基础紧急报警。</a:t>
             </a:r>
           </a:p>
         </p:txBody>
@@ -20005,7 +20005,7 @@
                 <a:latin typeface="Arial"/>
                 <a:ea typeface="微软雅黑"/>
               </a:rPr>
-              <a:t>自监督学习零标注成本——每个正常日子都是训练信号。14 天建立个人基线，3 个月比 14 天准，1 年比 3 个月准。用得越久切换成本越高：个人基线是用户的数据资产，换品牌意味着重新学习 14 天。固件精度停在出厂那天，世界模型每天都在进化——这是时间的朋友，不是用钱能加速的。</a:t>
+              <a:t>自监督学习零标注成本——每个正常日子都是训练信号。14 天建立个人基线，3 个月比 14 天准，1 年比 3 个月准。用得越久切换成本越高：个人基线是用户的数据资产，换品牌意味着重新学习 14 天。固件精度停在出厂那天，世界模型每天都在进化——时间的朋友效应，用钱无法加速。</a:t>
             </a:r>
           </a:p>
         </p:txBody>

</xml_diff>